<commit_message>
Name the project on the slide that introduces it
Slide 4 explained zero trust but never said what Mini ISE is, so after two
abstract scaling slides the audience still had no picture of the system.
It now names the project and shows its four pieces, with the zero-trust
framing moved into the spoken notes where it belongs.

Also states what is real and what is simulated, so nobody has to wonder.
</commit_message>
<xml_diff>
--- a/Mini-ISE-talk.pptx
+++ b/Mini-ISE-talk.pptx
@@ -1153,10 +1153,11 @@
             <a:r>
               <a:rPr lang="en-US" dirty="0"/>
               <a:t>So that’s the theory. Here’s the thing I built, and it has exactly that problem.
-In an old corporate network, once you were inside the building, you were trusted. Zero trust throws that out. Every single request gets checked, every time — it doesn’t matter that you checked thirty seconds ago.
-Mini ISE does exactly that. A device shows up and asks: can this user, on this laptop, from this location, reach the finance database right now? And a service answers one of three things — allow, deny, or quarantine — and it always gives a reason.
-That reason matters more than people expect. When someone gets locked out at nine in the morning, the help desk needs to know which rule did it.
-On the other side, admins manage those rules in a React console, and they can watch decisions stream in live.</a:t>
+Mini ISE is a small version of the software that decides which laptops and phones are allowed onto a company network. The real ones are big enterprise products — this is the same idea, small enough that I can explain all of it.
+The idea it implements is zero trust. In an old corporate network, once you were inside the building, you were trusted. Zero trust throws that out: every single request gets checked, every time, and it doesn’t matter that you checked thirty seconds ago.
+Four pieces. The decision service is the one that answers — a device asks "can this user, on this laptop, from this location, reach the finance database right now", and it says allow, deny or quarantine. Always with a reason, because when someone is locked out at nine in the morning, the help desk needs to know which rule did it.
+The policy API is where the rules live, and where an admin can describe a rule in plain English and have Claude draft it — a person still approves it before it goes live. The console is React: that’s where admins write rules and watch decisions arrive. And the simulator throws realistic device traffic at the whole thing so there is something to watch.
+Everything there is real except the devices. Real Python, real FastAPI, real Postgres, real Kubernetes.</a:t>
             </a:r>
             <a:endParaRPr lang="en-US" dirty="0"/>
           </a:p>
@@ -7634,7 +7635,7 @@
                 <a:ea typeface="Arial" pitchFamily="34" charset="-122"/>
                 <a:cs typeface="Arial" pitchFamily="34" charset="-120"/>
               </a:rPr>
-              <a:t>A laptop asks. Something has to answer.</a:t>
+              <a:t>Mini ISE, in four pieces</a:t>
             </a:r>
             <a:endParaRPr lang="en-US" sz="3200" dirty="0"/>
           </a:p>
@@ -7642,26 +7643,65 @@
       </p:sp>
       <p:sp>
         <p:nvSpPr>
-          <p:cNvPr id="3" name="Shape 1"/>
+          <p:cNvPr id="3" name="Text 1"/>
+          <p:cNvSpPr txBox="1"/>
+          <p:nvPr/>
+        </p:nvSpPr>
+        <p:spPr>
+          <a:xfrm>
+            <a:off x="731520" y="1188720"/>
+            <a:ext cx="10698480" cy="411480"/>
+          </a:xfrm>
+          <a:prstGeom prst="rect">
+            <a:avLst/>
+          </a:prstGeom>
+          <a:noFill/>
+          <a:ln/>
+        </p:spPr>
+        <p:txBody>
+          <a:bodyPr wrap="square" lIns="0" tIns="0" rIns="0" bIns="0" rtlCol="0" anchor="ctr"/>
+          <a:lstStyle/>
+          <a:p>
+            <a:pPr indent="0" marL="0">
+              <a:buNone/>
+            </a:pPr>
+            <a:r>
+              <a:rPr lang="en-US" sz="1800" dirty="0">
+                <a:solidFill>
+                  <a:srgbClr val="56625D"/>
+                </a:solidFill>
+                <a:latin typeface="Calibri" pitchFamily="34" charset="0"/>
+                <a:ea typeface="Calibri" pitchFamily="34" charset="-122"/>
+                <a:cs typeface="Calibri" pitchFamily="34" charset="-120"/>
+              </a:rPr>
+              <a:t>Who gets onto a company network — answered in under a millisecond.</a:t>
+            </a:r>
+            <a:endParaRPr lang="en-US" sz="1800" dirty="0"/>
+          </a:p>
+        </p:txBody>
+      </p:sp>
+      <p:sp>
+        <p:nvSpPr>
+          <p:cNvPr id="4" name="Shape 2"/>
           <p:cNvSpPr/>
           <p:nvPr/>
         </p:nvSpPr>
         <p:spPr>
           <a:xfrm>
-            <a:off x="731520" y="1463040"/>
-            <a:ext cx="3200400" cy="1051560"/>
+            <a:off x="731520" y="1828800"/>
+            <a:ext cx="5120640" cy="1371600"/>
           </a:xfrm>
           <a:prstGeom prst="roundRect">
             <a:avLst>
-              <a:gd name="adj" fmla="val 6957"/>
+              <a:gd name="adj" fmla="val 6667"/>
             </a:avLst>
           </a:prstGeom>
           <a:solidFill>
-            <a:srgbClr val="D4ECDD"/>
+            <a:srgbClr val="DDE3FB"/>
           </a:solidFill>
-          <a:ln w="15875">
+          <a:ln w="19050">
             <a:solidFill>
-              <a:srgbClr val="15804F"/>
+              <a:srgbClr val="2B45D9"/>
             </a:solidFill>
             <a:prstDash val="solid"/>
           </a:ln>
@@ -7669,69 +7709,69 @@
       </p:sp>
       <p:sp>
         <p:nvSpPr>
-          <p:cNvPr id="4" name="Text 2"/>
-          <p:cNvSpPr txBox="1"/>
-          <p:nvPr/>
-        </p:nvSpPr>
-        <p:spPr>
-          <a:xfrm>
-            <a:off x="731520" y="1600200"/>
-            <a:ext cx="3200400" cy="365760"/>
-          </a:xfrm>
-          <a:prstGeom prst="rect">
-            <a:avLst/>
-          </a:prstGeom>
-          <a:noFill/>
-          <a:ln/>
-        </p:spPr>
-        <p:txBody>
-          <a:bodyPr wrap="square" lIns="0" tIns="0" rIns="0" bIns="0" rtlCol="0" anchor="ctr"/>
-          <a:lstStyle/>
-          <a:p>
-            <a:pPr algn="ctr" indent="0" marL="0">
-              <a:buNone/>
-            </a:pPr>
-            <a:r>
-              <a:rPr lang="en-US" sz="1700" b="1" dirty="0">
-                <a:solidFill>
-                  <a:srgbClr val="15804F"/>
-                </a:solidFill>
-                <a:latin typeface="Arial" pitchFamily="34" charset="0"/>
-                <a:ea typeface="Arial" pitchFamily="34" charset="-122"/>
-                <a:cs typeface="Arial" pitchFamily="34" charset="-120"/>
-              </a:rPr>
-              <a:t>ALLOW</a:t>
-            </a:r>
-            <a:endParaRPr lang="en-US" sz="1700" dirty="0"/>
-          </a:p>
-        </p:txBody>
-      </p:sp>
-      <p:sp>
-        <p:nvSpPr>
           <p:cNvPr id="5" name="Text 3"/>
           <p:cNvSpPr txBox="1"/>
           <p:nvPr/>
         </p:nvSpPr>
         <p:spPr>
           <a:xfrm>
-            <a:off x="731520" y="2011680"/>
-            <a:ext cx="3200400" cy="320040"/>
-          </a:xfrm>
-          <a:prstGeom prst="rect">
-            <a:avLst/>
-          </a:prstGeom>
-          <a:noFill/>
-          <a:ln/>
-        </p:spPr>
-        <p:txBody>
-          <a:bodyPr wrap="square" lIns="0" tIns="0" rIns="0" bIns="0" rtlCol="0" anchor="ctr"/>
-          <a:lstStyle/>
-          <a:p>
-            <a:pPr algn="ctr" indent="0" marL="0">
-              <a:buNone/>
-            </a:pPr>
-            <a:r>
-              <a:rPr lang="en-US" sz="1200" dirty="0">
+            <a:off x="1051560" y="2048256"/>
+            <a:ext cx="4480560" cy="347472"/>
+          </a:xfrm>
+          <a:prstGeom prst="rect">
+            <a:avLst/>
+          </a:prstGeom>
+          <a:noFill/>
+          <a:ln/>
+        </p:spPr>
+        <p:txBody>
+          <a:bodyPr wrap="square" lIns="0" tIns="0" rIns="0" bIns="0" rtlCol="0" anchor="ctr"/>
+          <a:lstStyle/>
+          <a:p>
+            <a:pPr indent="0" marL="0">
+              <a:buNone/>
+            </a:pPr>
+            <a:r>
+              <a:rPr lang="en-US" sz="1400" b="1" dirty="0">
+                <a:solidFill>
+                  <a:srgbClr val="2B45D9"/>
+                </a:solidFill>
+                <a:latin typeface="Courier New" pitchFamily="34" charset="0"/>
+                <a:ea typeface="Courier New" pitchFamily="34" charset="-122"/>
+                <a:cs typeface="Courier New" pitchFamily="34" charset="-120"/>
+              </a:rPr>
+              <a:t>decision-service</a:t>
+            </a:r>
+            <a:endParaRPr lang="en-US" sz="1400" dirty="0"/>
+          </a:p>
+        </p:txBody>
+      </p:sp>
+      <p:sp>
+        <p:nvSpPr>
+          <p:cNvPr id="6" name="Text 4"/>
+          <p:cNvSpPr txBox="1"/>
+          <p:nvPr/>
+        </p:nvSpPr>
+        <p:spPr>
+          <a:xfrm>
+            <a:off x="1051560" y="2487168"/>
+            <a:ext cx="4480560" cy="548640"/>
+          </a:xfrm>
+          <a:prstGeom prst="rect">
+            <a:avLst/>
+          </a:prstGeom>
+          <a:noFill/>
+          <a:ln/>
+        </p:spPr>
+        <p:txBody>
+          <a:bodyPr wrap="square" lIns="0" tIns="0" rIns="0" bIns="0" rtlCol="0" anchor="ctr"/>
+          <a:lstStyle/>
+          <a:p>
+            <a:pPr indent="0" marL="0">
+              <a:buNone/>
+            </a:pPr>
+            <a:r>
+              <a:rPr lang="en-US" sz="1300" dirty="0">
                 <a:solidFill>
                   <a:srgbClr val="56625D"/>
                 </a:solidFill>
@@ -7739,34 +7779,34 @@
                 <a:ea typeface="Calibri" pitchFamily="34" charset="-122"/>
                 <a:cs typeface="Calibri" pitchFamily="34" charset="-120"/>
               </a:rPr>
-              <a:t>known device, known user</a:t>
-            </a:r>
-            <a:endParaRPr lang="en-US" sz="1200" dirty="0"/>
-          </a:p>
-        </p:txBody>
-      </p:sp>
-      <p:sp>
-        <p:nvSpPr>
-          <p:cNvPr id="6" name="Shape 4"/>
+              <a:t>Answers allow, deny or quarantine. The one under load.</a:t>
+            </a:r>
+            <a:endParaRPr lang="en-US" sz="1300" dirty="0"/>
+          </a:p>
+        </p:txBody>
+      </p:sp>
+      <p:sp>
+        <p:nvSpPr>
+          <p:cNvPr id="7" name="Shape 5"/>
           <p:cNvSpPr/>
           <p:nvPr/>
         </p:nvSpPr>
         <p:spPr>
           <a:xfrm>
-            <a:off x="4480560" y="1463040"/>
-            <a:ext cx="3200400" cy="1051560"/>
+            <a:off x="6309360" y="1828800"/>
+            <a:ext cx="5120640" cy="1371600"/>
           </a:xfrm>
           <a:prstGeom prst="roundRect">
             <a:avLst>
-              <a:gd name="adj" fmla="val 6957"/>
+              <a:gd name="adj" fmla="val 6667"/>
             </a:avLst>
           </a:prstGeom>
           <a:solidFill>
-            <a:srgbClr val="F5E6C6"/>
+            <a:srgbClr val="E9EDEA"/>
           </a:solidFill>
-          <a:ln w="15875">
+          <a:ln w="12700">
             <a:solidFill>
-              <a:srgbClr val="A8680A"/>
+              <a:srgbClr val="C9D2CD"/>
             </a:solidFill>
             <a:prstDash val="solid"/>
           </a:ln>
@@ -7774,69 +7814,69 @@
       </p:sp>
       <p:sp>
         <p:nvSpPr>
-          <p:cNvPr id="7" name="Text 5"/>
-          <p:cNvSpPr txBox="1"/>
-          <p:nvPr/>
-        </p:nvSpPr>
-        <p:spPr>
-          <a:xfrm>
-            <a:off x="4480560" y="1600200"/>
-            <a:ext cx="3200400" cy="365760"/>
-          </a:xfrm>
-          <a:prstGeom prst="rect">
-            <a:avLst/>
-          </a:prstGeom>
-          <a:noFill/>
-          <a:ln/>
-        </p:spPr>
-        <p:txBody>
-          <a:bodyPr wrap="square" lIns="0" tIns="0" rIns="0" bIns="0" rtlCol="0" anchor="ctr"/>
-          <a:lstStyle/>
-          <a:p>
-            <a:pPr algn="ctr" indent="0" marL="0">
-              <a:buNone/>
-            </a:pPr>
-            <a:r>
-              <a:rPr lang="en-US" sz="1700" b="1" dirty="0">
-                <a:solidFill>
-                  <a:srgbClr val="A8680A"/>
-                </a:solidFill>
-                <a:latin typeface="Arial" pitchFamily="34" charset="0"/>
-                <a:ea typeface="Arial" pitchFamily="34" charset="-122"/>
-                <a:cs typeface="Arial" pitchFamily="34" charset="-120"/>
-              </a:rPr>
-              <a:t>QUARANTINE</a:t>
-            </a:r>
-            <a:endParaRPr lang="en-US" sz="1700" dirty="0"/>
-          </a:p>
-        </p:txBody>
-      </p:sp>
-      <p:sp>
-        <p:nvSpPr>
           <p:cNvPr id="8" name="Text 6"/>
           <p:cNvSpPr txBox="1"/>
           <p:nvPr/>
         </p:nvSpPr>
         <p:spPr>
           <a:xfrm>
-            <a:off x="4480560" y="2011680"/>
-            <a:ext cx="3200400" cy="320040"/>
-          </a:xfrm>
-          <a:prstGeom prst="rect">
-            <a:avLst/>
-          </a:prstGeom>
-          <a:noFill/>
-          <a:ln/>
-        </p:spPr>
-        <p:txBody>
-          <a:bodyPr wrap="square" lIns="0" tIns="0" rIns="0" bIns="0" rtlCol="0" anchor="ctr"/>
-          <a:lstStyle/>
-          <a:p>
-            <a:pPr algn="ctr" indent="0" marL="0">
-              <a:buNone/>
-            </a:pPr>
-            <a:r>
-              <a:rPr lang="en-US" sz="1200" dirty="0">
+            <a:off x="6629400" y="2048256"/>
+            <a:ext cx="4480560" cy="347472"/>
+          </a:xfrm>
+          <a:prstGeom prst="rect">
+            <a:avLst/>
+          </a:prstGeom>
+          <a:noFill/>
+          <a:ln/>
+        </p:spPr>
+        <p:txBody>
+          <a:bodyPr wrap="square" lIns="0" tIns="0" rIns="0" bIns="0" rtlCol="0" anchor="ctr"/>
+          <a:lstStyle/>
+          <a:p>
+            <a:pPr indent="0" marL="0">
+              <a:buNone/>
+            </a:pPr>
+            <a:r>
+              <a:rPr lang="en-US" sz="1400" b="1" dirty="0">
+                <a:solidFill>
+                  <a:srgbClr val="111A17"/>
+                </a:solidFill>
+                <a:latin typeface="Courier New" pitchFamily="34" charset="0"/>
+                <a:ea typeface="Courier New" pitchFamily="34" charset="-122"/>
+                <a:cs typeface="Courier New" pitchFamily="34" charset="-120"/>
+              </a:rPr>
+              <a:t>policy-api</a:t>
+            </a:r>
+            <a:endParaRPr lang="en-US" sz="1400" dirty="0"/>
+          </a:p>
+        </p:txBody>
+      </p:sp>
+      <p:sp>
+        <p:nvSpPr>
+          <p:cNvPr id="9" name="Text 7"/>
+          <p:cNvSpPr txBox="1"/>
+          <p:nvPr/>
+        </p:nvSpPr>
+        <p:spPr>
+          <a:xfrm>
+            <a:off x="6629400" y="2487168"/>
+            <a:ext cx="4480560" cy="548640"/>
+          </a:xfrm>
+          <a:prstGeom prst="rect">
+            <a:avLst/>
+          </a:prstGeom>
+          <a:noFill/>
+          <a:ln/>
+        </p:spPr>
+        <p:txBody>
+          <a:bodyPr wrap="square" lIns="0" tIns="0" rIns="0" bIns="0" rtlCol="0" anchor="ctr"/>
+          <a:lstStyle/>
+          <a:p>
+            <a:pPr indent="0" marL="0">
+              <a:buNone/>
+            </a:pPr>
+            <a:r>
+              <a:rPr lang="en-US" sz="1300" dirty="0">
                 <a:solidFill>
                   <a:srgbClr val="56625D"/>
                 </a:solidFill>
@@ -7844,34 +7884,34 @@
                 <a:ea typeface="Calibri" pitchFamily="34" charset="-122"/>
                 <a:cs typeface="Calibri" pitchFamily="34" charset="-120"/>
               </a:rPr>
-              <a:t>let it on, but only just</a:t>
-            </a:r>
-            <a:endParaRPr lang="en-US" sz="1200" dirty="0"/>
-          </a:p>
-        </p:txBody>
-      </p:sp>
-      <p:sp>
-        <p:nvSpPr>
-          <p:cNvPr id="9" name="Shape 7"/>
+              <a:t>Where the rules live, and where Claude drafts them.</a:t>
+            </a:r>
+            <a:endParaRPr lang="en-US" sz="1300" dirty="0"/>
+          </a:p>
+        </p:txBody>
+      </p:sp>
+      <p:sp>
+        <p:nvSpPr>
+          <p:cNvPr id="10" name="Shape 8"/>
           <p:cNvSpPr/>
           <p:nvPr/>
         </p:nvSpPr>
         <p:spPr>
           <a:xfrm>
-            <a:off x="8229600" y="1463040"/>
-            <a:ext cx="3200400" cy="1051560"/>
+            <a:off x="731520" y="3429000"/>
+            <a:ext cx="5120640" cy="1371600"/>
           </a:xfrm>
           <a:prstGeom prst="roundRect">
             <a:avLst>
-              <a:gd name="adj" fmla="val 6957"/>
+              <a:gd name="adj" fmla="val 6667"/>
             </a:avLst>
           </a:prstGeom>
           <a:solidFill>
-            <a:srgbClr val="F5D9D4"/>
+            <a:srgbClr val="E9EDEA"/>
           </a:solidFill>
-          <a:ln w="15875">
+          <a:ln w="12700">
             <a:solidFill>
-              <a:srgbClr val="C0392B"/>
+              <a:srgbClr val="C9D2CD"/>
             </a:solidFill>
             <a:prstDash val="solid"/>
           </a:ln>
@@ -7879,69 +7919,69 @@
       </p:sp>
       <p:sp>
         <p:nvSpPr>
-          <p:cNvPr id="10" name="Text 8"/>
-          <p:cNvSpPr txBox="1"/>
-          <p:nvPr/>
-        </p:nvSpPr>
-        <p:spPr>
-          <a:xfrm>
-            <a:off x="8229600" y="1600200"/>
-            <a:ext cx="3200400" cy="365760"/>
-          </a:xfrm>
-          <a:prstGeom prst="rect">
-            <a:avLst/>
-          </a:prstGeom>
-          <a:noFill/>
-          <a:ln/>
-        </p:spPr>
-        <p:txBody>
-          <a:bodyPr wrap="square" lIns="0" tIns="0" rIns="0" bIns="0" rtlCol="0" anchor="ctr"/>
-          <a:lstStyle/>
-          <a:p>
-            <a:pPr algn="ctr" indent="0" marL="0">
-              <a:buNone/>
-            </a:pPr>
-            <a:r>
-              <a:rPr lang="en-US" sz="1700" b="1" dirty="0">
-                <a:solidFill>
-                  <a:srgbClr val="C0392B"/>
-                </a:solidFill>
-                <a:latin typeface="Arial" pitchFamily="34" charset="0"/>
-                <a:ea typeface="Arial" pitchFamily="34" charset="-122"/>
-                <a:cs typeface="Arial" pitchFamily="34" charset="-120"/>
-              </a:rPr>
-              <a:t>DENY</a:t>
-            </a:r>
-            <a:endParaRPr lang="en-US" sz="1700" dirty="0"/>
-          </a:p>
-        </p:txBody>
-      </p:sp>
-      <p:sp>
-        <p:nvSpPr>
           <p:cNvPr id="11" name="Text 9"/>
           <p:cNvSpPr txBox="1"/>
           <p:nvPr/>
         </p:nvSpPr>
         <p:spPr>
           <a:xfrm>
-            <a:off x="8229600" y="2011680"/>
-            <a:ext cx="3200400" cy="320040"/>
-          </a:xfrm>
-          <a:prstGeom prst="rect">
-            <a:avLst/>
-          </a:prstGeom>
-          <a:noFill/>
-          <a:ln/>
-        </p:spPr>
-        <p:txBody>
-          <a:bodyPr wrap="square" lIns="0" tIns="0" rIns="0" bIns="0" rtlCol="0" anchor="ctr"/>
-          <a:lstStyle/>
-          <a:p>
-            <a:pPr algn="ctr" indent="0" marL="0">
-              <a:buNone/>
-            </a:pPr>
-            <a:r>
-              <a:rPr lang="en-US" sz="1200" dirty="0">
+            <a:off x="1051560" y="3648456"/>
+            <a:ext cx="4480560" cy="347472"/>
+          </a:xfrm>
+          <a:prstGeom prst="rect">
+            <a:avLst/>
+          </a:prstGeom>
+          <a:noFill/>
+          <a:ln/>
+        </p:spPr>
+        <p:txBody>
+          <a:bodyPr wrap="square" lIns="0" tIns="0" rIns="0" bIns="0" rtlCol="0" anchor="ctr"/>
+          <a:lstStyle/>
+          <a:p>
+            <a:pPr indent="0" marL="0">
+              <a:buNone/>
+            </a:pPr>
+            <a:r>
+              <a:rPr lang="en-US" sz="1400" b="1" dirty="0">
+                <a:solidFill>
+                  <a:srgbClr val="111A17"/>
+                </a:solidFill>
+                <a:latin typeface="Courier New" pitchFamily="34" charset="0"/>
+                <a:ea typeface="Courier New" pitchFamily="34" charset="-122"/>
+                <a:cs typeface="Courier New" pitchFamily="34" charset="-120"/>
+              </a:rPr>
+              <a:t>console</a:t>
+            </a:r>
+            <a:endParaRPr lang="en-US" sz="1400" dirty="0"/>
+          </a:p>
+        </p:txBody>
+      </p:sp>
+      <p:sp>
+        <p:nvSpPr>
+          <p:cNvPr id="12" name="Text 10"/>
+          <p:cNvSpPr txBox="1"/>
+          <p:nvPr/>
+        </p:nvSpPr>
+        <p:spPr>
+          <a:xfrm>
+            <a:off x="1051560" y="4087368"/>
+            <a:ext cx="4480560" cy="548640"/>
+          </a:xfrm>
+          <a:prstGeom prst="rect">
+            <a:avLst/>
+          </a:prstGeom>
+          <a:noFill/>
+          <a:ln/>
+        </p:spPr>
+        <p:txBody>
+          <a:bodyPr wrap="square" lIns="0" tIns="0" rIns="0" bIns="0" rtlCol="0" anchor="ctr"/>
+          <a:lstStyle/>
+          <a:p>
+            <a:pPr indent="0" marL="0">
+              <a:buNone/>
+            </a:pPr>
+            <a:r>
+              <a:rPr lang="en-US" sz="1300" dirty="0">
                 <a:solidFill>
                   <a:srgbClr val="56625D"/>
                 </a:solidFill>
@@ -7949,115 +7989,153 @@
                 <a:ea typeface="Calibri" pitchFamily="34" charset="-122"/>
                 <a:cs typeface="Calibri" pitchFamily="34" charset="-120"/>
               </a:rPr>
-              <a:t>and say which rule did it</a:t>
-            </a:r>
-            <a:endParaRPr lang="en-US" sz="1200" dirty="0"/>
-          </a:p>
-        </p:txBody>
-      </p:sp>
-      <p:sp>
-        <p:nvSpPr>
-          <p:cNvPr id="12" name="Text 10"/>
-          <p:cNvSpPr txBox="1"/>
-          <p:nvPr/>
-        </p:nvSpPr>
-        <p:spPr>
-          <a:xfrm>
-            <a:off x="731520" y="3063240"/>
-            <a:ext cx="10698480" cy="2194560"/>
-          </a:xfrm>
-          <a:prstGeom prst="rect">
-            <a:avLst/>
-          </a:prstGeom>
-          <a:noFill/>
-          <a:ln/>
-        </p:spPr>
-        <p:txBody>
-          <a:bodyPr wrap="square" lIns="0" tIns="0" rIns="0" bIns="0" rtlCol="0" anchor="ctr"/>
-          <a:lstStyle/>
-          <a:p>
-            <a:pPr marL="342900" indent="-342900">
-              <a:spcAft>
-                <a:spcPts val="1000"/>
-              </a:spcAft>
-              <a:buSzPct val="100000"/>
-              <a:buChar char="•"/>
-            </a:pPr>
-            <a:r>
-              <a:rPr lang="en-US" sz="1700" dirty="0">
+              <a:t>React. Admins write rules and watch decisions land.</a:t>
+            </a:r>
+            <a:endParaRPr lang="en-US" sz="1300" dirty="0"/>
+          </a:p>
+        </p:txBody>
+      </p:sp>
+      <p:sp>
+        <p:nvSpPr>
+          <p:cNvPr id="13" name="Shape 11"/>
+          <p:cNvSpPr/>
+          <p:nvPr/>
+        </p:nvSpPr>
+        <p:spPr>
+          <a:xfrm>
+            <a:off x="6309360" y="3429000"/>
+            <a:ext cx="5120640" cy="1371600"/>
+          </a:xfrm>
+          <a:prstGeom prst="roundRect">
+            <a:avLst>
+              <a:gd name="adj" fmla="val 6667"/>
+            </a:avLst>
+          </a:prstGeom>
+          <a:solidFill>
+            <a:srgbClr val="E9EDEA"/>
+          </a:solidFill>
+          <a:ln w="12700">
+            <a:solidFill>
+              <a:srgbClr val="C9D2CD"/>
+            </a:solidFill>
+            <a:prstDash val="solid"/>
+          </a:ln>
+        </p:spPr>
+      </p:sp>
+      <p:sp>
+        <p:nvSpPr>
+          <p:cNvPr id="14" name="Text 12"/>
+          <p:cNvSpPr txBox="1"/>
+          <p:nvPr/>
+        </p:nvSpPr>
+        <p:spPr>
+          <a:xfrm>
+            <a:off x="6629400" y="3648456"/>
+            <a:ext cx="4480560" cy="347472"/>
+          </a:xfrm>
+          <a:prstGeom prst="rect">
+            <a:avLst/>
+          </a:prstGeom>
+          <a:noFill/>
+          <a:ln/>
+        </p:spPr>
+        <p:txBody>
+          <a:bodyPr wrap="square" lIns="0" tIns="0" rIns="0" bIns="0" rtlCol="0" anchor="ctr"/>
+          <a:lstStyle/>
+          <a:p>
+            <a:pPr indent="0" marL="0">
+              <a:buNone/>
+            </a:pPr>
+            <a:r>
+              <a:rPr lang="en-US" sz="1400" b="1" dirty="0">
                 <a:solidFill>
                   <a:srgbClr val="111A17"/>
+                </a:solidFill>
+                <a:latin typeface="Courier New" pitchFamily="34" charset="0"/>
+                <a:ea typeface="Courier New" pitchFamily="34" charset="-122"/>
+                <a:cs typeface="Courier New" pitchFamily="34" charset="-120"/>
+              </a:rPr>
+              <a:t>simulator</a:t>
+            </a:r>
+            <a:endParaRPr lang="en-US" sz="1400" dirty="0"/>
+          </a:p>
+        </p:txBody>
+      </p:sp>
+      <p:sp>
+        <p:nvSpPr>
+          <p:cNvPr id="15" name="Text 13"/>
+          <p:cNvSpPr txBox="1"/>
+          <p:nvPr/>
+        </p:nvSpPr>
+        <p:spPr>
+          <a:xfrm>
+            <a:off x="6629400" y="4087368"/>
+            <a:ext cx="4480560" cy="548640"/>
+          </a:xfrm>
+          <a:prstGeom prst="rect">
+            <a:avLst/>
+          </a:prstGeom>
+          <a:noFill/>
+          <a:ln/>
+        </p:spPr>
+        <p:txBody>
+          <a:bodyPr wrap="square" lIns="0" tIns="0" rIns="0" bIns="0" rtlCol="0" anchor="ctr"/>
+          <a:lstStyle/>
+          <a:p>
+            <a:pPr indent="0" marL="0">
+              <a:buNone/>
+            </a:pPr>
+            <a:r>
+              <a:rPr lang="en-US" sz="1300" dirty="0">
+                <a:solidFill>
+                  <a:srgbClr val="56625D"/>
                 </a:solidFill>
                 <a:latin typeface="Calibri" pitchFamily="34" charset="0"/>
                 <a:ea typeface="Calibri" pitchFamily="34" charset="-122"/>
                 <a:cs typeface="Calibri" pitchFamily="34" charset="-120"/>
               </a:rPr>
-              <a:t>Zero trust: every request checked, every time</a:t>
-            </a:r>
-            <a:endParaRPr lang="en-US" sz="1700" dirty="0"/>
-          </a:p>
-          <a:p>
-            <a:pPr marL="342900" indent="-342900">
-              <a:spcAft>
-                <a:spcPts val="1000"/>
-              </a:spcAft>
-              <a:buSzPct val="100000"/>
-              <a:buChar char="•"/>
-            </a:pPr>
-            <a:r>
-              <a:rPr lang="en-US" sz="1700" dirty="0">
-                <a:solidFill>
-                  <a:srgbClr val="111A17"/>
+              <a:t>Fake devices, so there is traffic to watch.</a:t>
+            </a:r>
+            <a:endParaRPr lang="en-US" sz="1300" dirty="0"/>
+          </a:p>
+        </p:txBody>
+      </p:sp>
+      <p:sp>
+        <p:nvSpPr>
+          <p:cNvPr id="16" name="Text 14"/>
+          <p:cNvSpPr txBox="1"/>
+          <p:nvPr/>
+        </p:nvSpPr>
+        <p:spPr>
+          <a:xfrm>
+            <a:off x="731520" y="5212080"/>
+            <a:ext cx="10698480" cy="365760"/>
+          </a:xfrm>
+          <a:prstGeom prst="rect">
+            <a:avLst/>
+          </a:prstGeom>
+          <a:noFill/>
+          <a:ln/>
+        </p:spPr>
+        <p:txBody>
+          <a:bodyPr wrap="square" lIns="0" tIns="0" rIns="0" bIns="0" rtlCol="0" anchor="ctr"/>
+          <a:lstStyle/>
+          <a:p>
+            <a:pPr indent="0" marL="0">
+              <a:buNone/>
+            </a:pPr>
+            <a:r>
+              <a:rPr lang="en-US" sz="1300" dirty="0">
+                <a:solidFill>
+                  <a:srgbClr val="56625D"/>
                 </a:solidFill>
                 <a:latin typeface="Calibri" pitchFamily="34" charset="0"/>
                 <a:ea typeface="Calibri" pitchFamily="34" charset="-122"/>
                 <a:cs typeface="Calibri" pitchFamily="34" charset="-120"/>
               </a:rPr>
-              <a:t>A device asks for access to a resource</a:t>
-            </a:r>
-            <a:endParaRPr lang="en-US" sz="1700" dirty="0"/>
-          </a:p>
-          <a:p>
-            <a:pPr marL="342900" indent="-342900">
-              <a:spcAft>
-                <a:spcPts val="1000"/>
-              </a:spcAft>
-              <a:buSzPct val="100000"/>
-              <a:buChar char="•"/>
-            </a:pPr>
-            <a:r>
-              <a:rPr lang="en-US" sz="1700" dirty="0">
-                <a:solidFill>
-                  <a:srgbClr val="111A17"/>
-                </a:solidFill>
-                <a:latin typeface="Calibri" pitchFamily="34" charset="0"/>
-                <a:ea typeface="Calibri" pitchFamily="34" charset="-122"/>
-                <a:cs typeface="Calibri" pitchFamily="34" charset="-120"/>
-              </a:rPr>
-              <a:t>A service answers allow, deny or quarantine — always with a reason</a:t>
-            </a:r>
-            <a:endParaRPr lang="en-US" sz="1700" dirty="0"/>
-          </a:p>
-          <a:p>
-            <a:pPr marL="342900" indent="-342900">
-              <a:spcAft>
-                <a:spcPts val="1000"/>
-              </a:spcAft>
-              <a:buSzPct val="100000"/>
-              <a:buChar char="•"/>
-            </a:pPr>
-            <a:r>
-              <a:rPr lang="en-US" sz="1700" dirty="0">
-                <a:solidFill>
-                  <a:srgbClr val="111A17"/>
-                </a:solidFill>
-                <a:latin typeface="Calibri" pitchFamily="34" charset="0"/>
-                <a:ea typeface="Calibri" pitchFamily="34" charset="-122"/>
-                <a:cs typeface="Calibri" pitchFamily="34" charset="-120"/>
-              </a:rPr>
-              <a:t>Admins manage the rules in a React console</a:t>
-            </a:r>
-            <a:endParaRPr lang="en-US" sz="1700" dirty="0"/>
+              <a:t>Real Python, FastAPI, Postgres and Kubernetes. The only invented part is the devices.</a:t>
+            </a:r>
+            <a:endParaRPr lang="en-US" sz="1300" dirty="0"/>
           </a:p>
         </p:txBody>
       </p:sp>

</xml_diff>